<commit_message>
Improve demo questions, doc grader strictness, and documentation
- Replace sample questions with tested MCP/RAG scenarios (5+5)
- Tighten Doc Grader prompt to reduce false positives
- Add Known Limitations section to README with MCP faithfulness analysis
- Expand Executive Summary with pipeline flow, Why RAGAS, Why LangFuse
- Fix presentation: My AI assistant, remove TypedDict, reasoning→re-ranking
- Add Future Improvements: parallel hybrid search for latency

Co-Authored-By: Claude Sonnet 4.6 <noreply@anthropic.com>
</commit_message>
<xml_diff>
--- a/Capstone_Presentation.pptx
+++ b/Capstone_Presentation.pptx
@@ -6180,7 +6180,7 @@
                   <a:srgbClr val="10B981"/>
                 </a:solidFill>
               </a:rPr>
-              <a:t>🤖  Our AI (1 query)</a:t>
+              <a:t>🤖  My AI assistant (1 query)</a:t>
             </a:r>
           </a:p>
         </p:txBody>
@@ -6666,8 +6666,7 @@
                 </a:solidFill>
               </a:rPr>
               <a:t>Agentic orchestration
-11 nodes, conditional routing
-TypedDict state management</a:t>
+11 nodes, conditional routing</a:t>
             </a:r>
           </a:p>
         </p:txBody>
@@ -6861,7 +6860,7 @@
               </a:rPr>
               <a:t>LLM for all agents
 Generation, grading
-&amp; reasoning</a:t>
+&amp; re-ranking</a:t>
             </a:r>
           </a:p>
         </p:txBody>

</xml_diff>

<commit_message>
Update presentation: 3 agents, RAGAS cost included, v4 diagram
- Slide 1 stats: "7 AI Agents" → "3 Agents", "11 Nodes" → "8 Pipeline Steps"
- Slide 2 cost: added "incl. RAGAS eval" to Our AI card
- Slide 3 LangGraph card: "11 nodes" → "3 agents, 8 pipeline steps"
- Slide 4: updated diagram to architecture_diagram_v4.png

Co-Authored-By: Claude Sonnet 4.6 <noreply@anthropic.com>
</commit_message>
<xml_diff>
--- a/Capstone_Presentation.pptx
+++ b/Capstone_Presentation.pptx
@@ -5,13 +5,13 @@
     <p:sldMasterId id="2147483648" r:id="rId1"/>
   </p:sldMasterIdLst>
   <p:sldIdLst>
-    <p:sldId id="256" r:id="rId2"/>
-    <p:sldId id="257" r:id="rId3"/>
-    <p:sldId id="258" r:id="rId4"/>
-    <p:sldId id="259" r:id="rId5"/>
-    <p:sldId id="260" r:id="rId6"/>
+    <p:sldId id="256" r:id="rId7"/>
+    <p:sldId id="257" r:id="rId8"/>
+    <p:sldId id="258" r:id="rId9"/>
+    <p:sldId id="259" r:id="rId10"/>
+    <p:sldId id="260" r:id="rId11"/>
   </p:sldIdLst>
-  <p:sldSz cx="12188825" cy="6858000"/>
+  <p:sldSz cx="12188952" cy="6858000" type="screen4x3"/>
   <p:notesSz cx="6858000" cy="9144000"/>
   <p:defaultTextStyle>
     <a:defPPr>
@@ -108,22 +108,6 @@
       </a:defRPr>
     </a:lvl9pPr>
   </p:defaultTextStyle>
-  <p:extLst>
-    <p:ext uri="{EFAFB233-063F-42B5-8137-9DF3F51BA10A}">
-      <p15:sldGuideLst xmlns:p15="http://schemas.microsoft.com/office/powerpoint/2012/main">
-        <p15:guide id="1" orient="horz" pos="2160">
-          <p15:clr>
-            <a:srgbClr val="A4A3A4"/>
-          </p15:clr>
-        </p15:guide>
-        <p15:guide id="2" pos="2880">
-          <p15:clr>
-            <a:srgbClr val="A4A3A4"/>
-          </p15:clr>
-        </p15:guide>
-      </p15:sldGuideLst>
-    </p:ext>
-  </p:extLst>
 </p:presentation>
 </file>
 
@@ -165,9 +149,10 @@
           <a:lstStyle/>
           <a:p>
             <a:r>
-              <a:rPr lang="en-US"/>
+              <a:rPr lang="en-US" smtClean="0"/>
               <a:t>Click to edit Master title style</a:t>
             </a:r>
+            <a:endParaRPr lang="en-US"/>
           </a:p>
         </p:txBody>
       </p:sp>
@@ -283,9 +268,10 @@
           </a:lstStyle>
           <a:p>
             <a:r>
-              <a:rPr lang="en-US"/>
+              <a:rPr lang="en-US" smtClean="0"/>
               <a:t>Click to edit Master subtitle style</a:t>
             </a:r>
+            <a:endParaRPr lang="en-US"/>
           </a:p>
         </p:txBody>
       </p:sp>
@@ -306,7 +292,7 @@
           <a:p>
             <a:fld id="{5BCAD085-E8A6-8845-BD4E-CB4CCA059FC4}" type="datetimeFigureOut">
               <a:rPr lang="en-US" smtClean="0"/>
-              <a:t>5/7/2026</a:t>
+              <a:t>1/27/13</a:t>
             </a:fld>
             <a:endParaRPr lang="en-US"/>
           </a:p>
@@ -400,9 +386,10 @@
           <a:lstStyle/>
           <a:p>
             <a:r>
-              <a:rPr lang="en-US"/>
+              <a:rPr lang="en-US" smtClean="0"/>
               <a:t>Click to edit Master title style</a:t>
             </a:r>
+            <a:endParaRPr lang="en-US"/>
           </a:p>
         </p:txBody>
       </p:sp>
@@ -423,37 +410,38 @@
           <a:p>
             <a:pPr lvl="0"/>
             <a:r>
-              <a:rPr lang="en-US"/>
+              <a:rPr lang="en-US" smtClean="0"/>
               <a:t>Click to edit Master text styles</a:t>
             </a:r>
           </a:p>
           <a:p>
             <a:pPr lvl="1"/>
             <a:r>
-              <a:rPr lang="en-US"/>
+              <a:rPr lang="en-US" smtClean="0"/>
               <a:t>Second level</a:t>
             </a:r>
           </a:p>
           <a:p>
             <a:pPr lvl="2"/>
             <a:r>
-              <a:rPr lang="en-US"/>
+              <a:rPr lang="en-US" smtClean="0"/>
               <a:t>Third level</a:t>
             </a:r>
           </a:p>
           <a:p>
             <a:pPr lvl="3"/>
             <a:r>
-              <a:rPr lang="en-US"/>
+              <a:rPr lang="en-US" smtClean="0"/>
               <a:t>Fourth level</a:t>
             </a:r>
           </a:p>
           <a:p>
             <a:pPr lvl="4"/>
             <a:r>
-              <a:rPr lang="en-US"/>
+              <a:rPr lang="en-US" smtClean="0"/>
               <a:t>Fifth level</a:t>
             </a:r>
+            <a:endParaRPr lang="en-US"/>
           </a:p>
         </p:txBody>
       </p:sp>
@@ -474,7 +462,7 @@
           <a:p>
             <a:fld id="{5BCAD085-E8A6-8845-BD4E-CB4CCA059FC4}" type="datetimeFigureOut">
               <a:rPr lang="en-US" smtClean="0"/>
-              <a:t>5/7/2026</a:t>
+              <a:t>1/27/13</a:t>
             </a:fld>
             <a:endParaRPr lang="en-US"/>
           </a:p>
@@ -573,9 +561,10 @@
           <a:lstStyle/>
           <a:p>
             <a:r>
-              <a:rPr lang="en-US"/>
+              <a:rPr lang="en-US" smtClean="0"/>
               <a:t>Click to edit Master title style</a:t>
             </a:r>
+            <a:endParaRPr lang="en-US"/>
           </a:p>
         </p:txBody>
       </p:sp>
@@ -601,37 +590,38 @@
           <a:p>
             <a:pPr lvl="0"/>
             <a:r>
-              <a:rPr lang="en-US"/>
+              <a:rPr lang="en-US" smtClean="0"/>
               <a:t>Click to edit Master text styles</a:t>
             </a:r>
           </a:p>
           <a:p>
             <a:pPr lvl="1"/>
             <a:r>
-              <a:rPr lang="en-US"/>
+              <a:rPr lang="en-US" smtClean="0"/>
               <a:t>Second level</a:t>
             </a:r>
           </a:p>
           <a:p>
             <a:pPr lvl="2"/>
             <a:r>
-              <a:rPr lang="en-US"/>
+              <a:rPr lang="en-US" smtClean="0"/>
               <a:t>Third level</a:t>
             </a:r>
           </a:p>
           <a:p>
             <a:pPr lvl="3"/>
             <a:r>
-              <a:rPr lang="en-US"/>
+              <a:rPr lang="en-US" smtClean="0"/>
               <a:t>Fourth level</a:t>
             </a:r>
           </a:p>
           <a:p>
             <a:pPr lvl="4"/>
             <a:r>
-              <a:rPr lang="en-US"/>
+              <a:rPr lang="en-US" smtClean="0"/>
               <a:t>Fifth level</a:t>
             </a:r>
+            <a:endParaRPr lang="en-US"/>
           </a:p>
         </p:txBody>
       </p:sp>
@@ -652,7 +642,7 @@
           <a:p>
             <a:fld id="{5BCAD085-E8A6-8845-BD4E-CB4CCA059FC4}" type="datetimeFigureOut">
               <a:rPr lang="en-US" smtClean="0"/>
-              <a:t>5/7/2026</a:t>
+              <a:t>1/27/13</a:t>
             </a:fld>
             <a:endParaRPr lang="en-US"/>
           </a:p>
@@ -746,9 +736,10 @@
           <a:lstStyle/>
           <a:p>
             <a:r>
-              <a:rPr lang="en-US"/>
+              <a:rPr lang="en-US" smtClean="0"/>
               <a:t>Click to edit Master title style</a:t>
             </a:r>
+            <a:endParaRPr lang="en-US"/>
           </a:p>
         </p:txBody>
       </p:sp>
@@ -769,37 +760,38 @@
           <a:p>
             <a:pPr lvl="0"/>
             <a:r>
-              <a:rPr lang="en-US"/>
+              <a:rPr lang="en-US" smtClean="0"/>
               <a:t>Click to edit Master text styles</a:t>
             </a:r>
           </a:p>
           <a:p>
             <a:pPr lvl="1"/>
             <a:r>
-              <a:rPr lang="en-US"/>
+              <a:rPr lang="en-US" smtClean="0"/>
               <a:t>Second level</a:t>
             </a:r>
           </a:p>
           <a:p>
             <a:pPr lvl="2"/>
             <a:r>
-              <a:rPr lang="en-US"/>
+              <a:rPr lang="en-US" smtClean="0"/>
               <a:t>Third level</a:t>
             </a:r>
           </a:p>
           <a:p>
             <a:pPr lvl="3"/>
             <a:r>
-              <a:rPr lang="en-US"/>
+              <a:rPr lang="en-US" smtClean="0"/>
               <a:t>Fourth level</a:t>
             </a:r>
           </a:p>
           <a:p>
             <a:pPr lvl="4"/>
             <a:r>
-              <a:rPr lang="en-US"/>
+              <a:rPr lang="en-US" smtClean="0"/>
               <a:t>Fifth level</a:t>
             </a:r>
+            <a:endParaRPr lang="en-US"/>
           </a:p>
         </p:txBody>
       </p:sp>
@@ -820,7 +812,7 @@
           <a:p>
             <a:fld id="{5BCAD085-E8A6-8845-BD4E-CB4CCA059FC4}" type="datetimeFigureOut">
               <a:rPr lang="en-US" smtClean="0"/>
-              <a:t>5/7/2026</a:t>
+              <a:t>1/27/13</a:t>
             </a:fld>
             <a:endParaRPr lang="en-US"/>
           </a:p>
@@ -923,9 +915,10 @@
           </a:lstStyle>
           <a:p>
             <a:r>
-              <a:rPr lang="en-US"/>
+              <a:rPr lang="en-US" smtClean="0"/>
               <a:t>Click to edit Master title style</a:t>
             </a:r>
+            <a:endParaRPr lang="en-US"/>
           </a:p>
         </p:txBody>
       </p:sp>
@@ -1042,7 +1035,7 @@
           <a:p>
             <a:pPr lvl="0"/>
             <a:r>
-              <a:rPr lang="en-US"/>
+              <a:rPr lang="en-US" smtClean="0"/>
               <a:t>Click to edit Master text styles</a:t>
             </a:r>
           </a:p>
@@ -1065,7 +1058,7 @@
           <a:p>
             <a:fld id="{5BCAD085-E8A6-8845-BD4E-CB4CCA059FC4}" type="datetimeFigureOut">
               <a:rPr lang="en-US" smtClean="0"/>
-              <a:t>5/7/2026</a:t>
+              <a:t>1/27/13</a:t>
             </a:fld>
             <a:endParaRPr lang="en-US"/>
           </a:p>
@@ -1159,9 +1152,10 @@
           <a:lstStyle/>
           <a:p>
             <a:r>
-              <a:rPr lang="en-US"/>
+              <a:rPr lang="en-US" smtClean="0"/>
               <a:t>Click to edit Master title style</a:t>
             </a:r>
+            <a:endParaRPr lang="en-US"/>
           </a:p>
         </p:txBody>
       </p:sp>
@@ -1215,37 +1209,38 @@
           <a:p>
             <a:pPr lvl="0"/>
             <a:r>
-              <a:rPr lang="en-US"/>
+              <a:rPr lang="en-US" smtClean="0"/>
               <a:t>Click to edit Master text styles</a:t>
             </a:r>
           </a:p>
           <a:p>
             <a:pPr lvl="1"/>
             <a:r>
-              <a:rPr lang="en-US"/>
+              <a:rPr lang="en-US" smtClean="0"/>
               <a:t>Second level</a:t>
             </a:r>
           </a:p>
           <a:p>
             <a:pPr lvl="2"/>
             <a:r>
-              <a:rPr lang="en-US"/>
+              <a:rPr lang="en-US" smtClean="0"/>
               <a:t>Third level</a:t>
             </a:r>
           </a:p>
           <a:p>
             <a:pPr lvl="3"/>
             <a:r>
-              <a:rPr lang="en-US"/>
+              <a:rPr lang="en-US" smtClean="0"/>
               <a:t>Fourth level</a:t>
             </a:r>
           </a:p>
           <a:p>
             <a:pPr lvl="4"/>
             <a:r>
-              <a:rPr lang="en-US"/>
+              <a:rPr lang="en-US" smtClean="0"/>
               <a:t>Fifth level</a:t>
             </a:r>
+            <a:endParaRPr lang="en-US"/>
           </a:p>
         </p:txBody>
       </p:sp>
@@ -1299,37 +1294,38 @@
           <a:p>
             <a:pPr lvl="0"/>
             <a:r>
-              <a:rPr lang="en-US"/>
+              <a:rPr lang="en-US" smtClean="0"/>
               <a:t>Click to edit Master text styles</a:t>
             </a:r>
           </a:p>
           <a:p>
             <a:pPr lvl="1"/>
             <a:r>
-              <a:rPr lang="en-US"/>
+              <a:rPr lang="en-US" smtClean="0"/>
               <a:t>Second level</a:t>
             </a:r>
           </a:p>
           <a:p>
             <a:pPr lvl="2"/>
             <a:r>
-              <a:rPr lang="en-US"/>
+              <a:rPr lang="en-US" smtClean="0"/>
               <a:t>Third level</a:t>
             </a:r>
           </a:p>
           <a:p>
             <a:pPr lvl="3"/>
             <a:r>
-              <a:rPr lang="en-US"/>
+              <a:rPr lang="en-US" smtClean="0"/>
               <a:t>Fourth level</a:t>
             </a:r>
           </a:p>
           <a:p>
             <a:pPr lvl="4"/>
             <a:r>
-              <a:rPr lang="en-US"/>
+              <a:rPr lang="en-US" smtClean="0"/>
               <a:t>Fifth level</a:t>
             </a:r>
+            <a:endParaRPr lang="en-US"/>
           </a:p>
         </p:txBody>
       </p:sp>
@@ -1350,7 +1346,7 @@
           <a:p>
             <a:fld id="{5BCAD085-E8A6-8845-BD4E-CB4CCA059FC4}" type="datetimeFigureOut">
               <a:rPr lang="en-US" smtClean="0"/>
-              <a:t>5/7/2026</a:t>
+              <a:t>1/27/13</a:t>
             </a:fld>
             <a:endParaRPr lang="en-US"/>
           </a:p>
@@ -1448,9 +1444,10 @@
           </a:lstStyle>
           <a:p>
             <a:r>
-              <a:rPr lang="en-US"/>
+              <a:rPr lang="en-US" smtClean="0"/>
               <a:t>Click to edit Master title style</a:t>
             </a:r>
+            <a:endParaRPr lang="en-US"/>
           </a:p>
         </p:txBody>
       </p:sp>
@@ -1513,7 +1510,7 @@
           <a:p>
             <a:pPr lvl="0"/>
             <a:r>
-              <a:rPr lang="en-US"/>
+              <a:rPr lang="en-US" smtClean="0"/>
               <a:t>Click to edit Master text styles</a:t>
             </a:r>
           </a:p>
@@ -1569,37 +1566,38 @@
           <a:p>
             <a:pPr lvl="0"/>
             <a:r>
-              <a:rPr lang="en-US"/>
+              <a:rPr lang="en-US" smtClean="0"/>
               <a:t>Click to edit Master text styles</a:t>
             </a:r>
           </a:p>
           <a:p>
             <a:pPr lvl="1"/>
             <a:r>
-              <a:rPr lang="en-US"/>
+              <a:rPr lang="en-US" smtClean="0"/>
               <a:t>Second level</a:t>
             </a:r>
           </a:p>
           <a:p>
             <a:pPr lvl="2"/>
             <a:r>
-              <a:rPr lang="en-US"/>
+              <a:rPr lang="en-US" smtClean="0"/>
               <a:t>Third level</a:t>
             </a:r>
           </a:p>
           <a:p>
             <a:pPr lvl="3"/>
             <a:r>
-              <a:rPr lang="en-US"/>
+              <a:rPr lang="en-US" smtClean="0"/>
               <a:t>Fourth level</a:t>
             </a:r>
           </a:p>
           <a:p>
             <a:pPr lvl="4"/>
             <a:r>
-              <a:rPr lang="en-US"/>
+              <a:rPr lang="en-US" smtClean="0"/>
               <a:t>Fifth level</a:t>
             </a:r>
+            <a:endParaRPr lang="en-US"/>
           </a:p>
         </p:txBody>
       </p:sp>
@@ -1662,7 +1660,7 @@
           <a:p>
             <a:pPr lvl="0"/>
             <a:r>
-              <a:rPr lang="en-US"/>
+              <a:rPr lang="en-US" smtClean="0"/>
               <a:t>Click to edit Master text styles</a:t>
             </a:r>
           </a:p>
@@ -1718,37 +1716,38 @@
           <a:p>
             <a:pPr lvl="0"/>
             <a:r>
-              <a:rPr lang="en-US"/>
+              <a:rPr lang="en-US" smtClean="0"/>
               <a:t>Click to edit Master text styles</a:t>
             </a:r>
           </a:p>
           <a:p>
             <a:pPr lvl="1"/>
             <a:r>
-              <a:rPr lang="en-US"/>
+              <a:rPr lang="en-US" smtClean="0"/>
               <a:t>Second level</a:t>
             </a:r>
           </a:p>
           <a:p>
             <a:pPr lvl="2"/>
             <a:r>
-              <a:rPr lang="en-US"/>
+              <a:rPr lang="en-US" smtClean="0"/>
               <a:t>Third level</a:t>
             </a:r>
           </a:p>
           <a:p>
             <a:pPr lvl="3"/>
             <a:r>
-              <a:rPr lang="en-US"/>
+              <a:rPr lang="en-US" smtClean="0"/>
               <a:t>Fourth level</a:t>
             </a:r>
           </a:p>
           <a:p>
             <a:pPr lvl="4"/>
             <a:r>
-              <a:rPr lang="en-US"/>
+              <a:rPr lang="en-US" smtClean="0"/>
               <a:t>Fifth level</a:t>
             </a:r>
+            <a:endParaRPr lang="en-US"/>
           </a:p>
         </p:txBody>
       </p:sp>
@@ -1769,7 +1768,7 @@
           <a:p>
             <a:fld id="{5BCAD085-E8A6-8845-BD4E-CB4CCA059FC4}" type="datetimeFigureOut">
               <a:rPr lang="en-US" smtClean="0"/>
-              <a:t>5/7/2026</a:t>
+              <a:t>1/27/13</a:t>
             </a:fld>
             <a:endParaRPr lang="en-US"/>
           </a:p>
@@ -1863,9 +1862,10 @@
           <a:lstStyle/>
           <a:p>
             <a:r>
-              <a:rPr lang="en-US"/>
+              <a:rPr lang="en-US" smtClean="0"/>
               <a:t>Click to edit Master title style</a:t>
             </a:r>
+            <a:endParaRPr lang="en-US"/>
           </a:p>
         </p:txBody>
       </p:sp>
@@ -1886,7 +1886,7 @@
           <a:p>
             <a:fld id="{5BCAD085-E8A6-8845-BD4E-CB4CCA059FC4}" type="datetimeFigureOut">
               <a:rPr lang="en-US" smtClean="0"/>
-              <a:t>5/7/2026</a:t>
+              <a:t>1/27/13</a:t>
             </a:fld>
             <a:endParaRPr lang="en-US"/>
           </a:p>
@@ -1981,7 +1981,7 @@
           <a:p>
             <a:fld id="{5BCAD085-E8A6-8845-BD4E-CB4CCA059FC4}" type="datetimeFigureOut">
               <a:rPr lang="en-US" smtClean="0"/>
-              <a:t>5/7/2026</a:t>
+              <a:t>1/27/13</a:t>
             </a:fld>
             <a:endParaRPr lang="en-US"/>
           </a:p>
@@ -2084,9 +2084,10 @@
           </a:lstStyle>
           <a:p>
             <a:r>
-              <a:rPr lang="en-US"/>
+              <a:rPr lang="en-US" smtClean="0"/>
               <a:t>Click to edit Master title style</a:t>
             </a:r>
+            <a:endParaRPr lang="en-US"/>
           </a:p>
         </p:txBody>
       </p:sp>
@@ -2140,37 +2141,38 @@
           <a:p>
             <a:pPr lvl="0"/>
             <a:r>
-              <a:rPr lang="en-US"/>
+              <a:rPr lang="en-US" smtClean="0"/>
               <a:t>Click to edit Master text styles</a:t>
             </a:r>
           </a:p>
           <a:p>
             <a:pPr lvl="1"/>
             <a:r>
-              <a:rPr lang="en-US"/>
+              <a:rPr lang="en-US" smtClean="0"/>
               <a:t>Second level</a:t>
             </a:r>
           </a:p>
           <a:p>
             <a:pPr lvl="2"/>
             <a:r>
-              <a:rPr lang="en-US"/>
+              <a:rPr lang="en-US" smtClean="0"/>
               <a:t>Third level</a:t>
             </a:r>
           </a:p>
           <a:p>
             <a:pPr lvl="3"/>
             <a:r>
-              <a:rPr lang="en-US"/>
+              <a:rPr lang="en-US" smtClean="0"/>
               <a:t>Fourth level</a:t>
             </a:r>
           </a:p>
           <a:p>
             <a:pPr lvl="4"/>
             <a:r>
-              <a:rPr lang="en-US"/>
+              <a:rPr lang="en-US" smtClean="0"/>
               <a:t>Fifth level</a:t>
             </a:r>
+            <a:endParaRPr lang="en-US"/>
           </a:p>
         </p:txBody>
       </p:sp>
@@ -2233,7 +2235,7 @@
           <a:p>
             <a:pPr lvl="0"/>
             <a:r>
-              <a:rPr lang="en-US"/>
+              <a:rPr lang="en-US" smtClean="0"/>
               <a:t>Click to edit Master text styles</a:t>
             </a:r>
           </a:p>
@@ -2256,7 +2258,7 @@
           <a:p>
             <a:fld id="{5BCAD085-E8A6-8845-BD4E-CB4CCA059FC4}" type="datetimeFigureOut">
               <a:rPr lang="en-US" smtClean="0"/>
-              <a:t>5/7/2026</a:t>
+              <a:t>1/27/13</a:t>
             </a:fld>
             <a:endParaRPr lang="en-US"/>
           </a:p>
@@ -2359,9 +2361,10 @@
           </a:lstStyle>
           <a:p>
             <a:r>
-              <a:rPr lang="en-US"/>
+              <a:rPr lang="en-US" smtClean="0"/>
               <a:t>Click to edit Master title style</a:t>
             </a:r>
+            <a:endParaRPr lang="en-US"/>
           </a:p>
         </p:txBody>
       </p:sp>
@@ -2485,7 +2488,7 @@
           <a:p>
             <a:pPr lvl="0"/>
             <a:r>
-              <a:rPr lang="en-US"/>
+              <a:rPr lang="en-US" smtClean="0"/>
               <a:t>Click to edit Master text styles</a:t>
             </a:r>
           </a:p>
@@ -2508,7 +2511,7 @@
           <a:p>
             <a:fld id="{5BCAD085-E8A6-8845-BD4E-CB4CCA059FC4}" type="datetimeFigureOut">
               <a:rPr lang="en-US" smtClean="0"/>
-              <a:t>5/7/2026</a:t>
+              <a:t>1/27/13</a:t>
             </a:fld>
             <a:endParaRPr lang="en-US"/>
           </a:p>
@@ -2617,9 +2620,10 @@
           <a:lstStyle/>
           <a:p>
             <a:r>
-              <a:rPr lang="en-US"/>
+              <a:rPr lang="en-US" smtClean="0"/>
               <a:t>Click to edit Master title style</a:t>
             </a:r>
+            <a:endParaRPr lang="en-US"/>
           </a:p>
         </p:txBody>
       </p:sp>
@@ -2650,37 +2654,38 @@
           <a:p>
             <a:pPr lvl="0"/>
             <a:r>
-              <a:rPr lang="en-US"/>
+              <a:rPr lang="en-US" smtClean="0"/>
               <a:t>Click to edit Master text styles</a:t>
             </a:r>
           </a:p>
           <a:p>
             <a:pPr lvl="1"/>
             <a:r>
-              <a:rPr lang="en-US"/>
+              <a:rPr lang="en-US" smtClean="0"/>
               <a:t>Second level</a:t>
             </a:r>
           </a:p>
           <a:p>
             <a:pPr lvl="2"/>
             <a:r>
-              <a:rPr lang="en-US"/>
+              <a:rPr lang="en-US" smtClean="0"/>
               <a:t>Third level</a:t>
             </a:r>
           </a:p>
           <a:p>
             <a:pPr lvl="3"/>
             <a:r>
-              <a:rPr lang="en-US"/>
+              <a:rPr lang="en-US" smtClean="0"/>
               <a:t>Fourth level</a:t>
             </a:r>
           </a:p>
           <a:p>
             <a:pPr lvl="4"/>
             <a:r>
-              <a:rPr lang="en-US"/>
+              <a:rPr lang="en-US" smtClean="0"/>
               <a:t>Fifth level</a:t>
             </a:r>
+            <a:endParaRPr lang="en-US"/>
           </a:p>
         </p:txBody>
       </p:sp>
@@ -2719,7 +2724,7 @@
           <a:p>
             <a:fld id="{5BCAD085-E8A6-8845-BD4E-CB4CCA059FC4}" type="datetimeFigureOut">
               <a:rPr lang="en-US" smtClean="0"/>
-              <a:t>5/7/2026</a:t>
+              <a:t>1/27/13</a:t>
             </a:fld>
             <a:endParaRPr lang="en-US"/>
           </a:p>
@@ -3078,7 +3083,7 @@
 </file>
 
 <file path=ppt/slides/slide1.xml><?xml version="1.0" encoding="utf-8"?>
-<p:sld xmlns:a="http://schemas.openxmlformats.org/drawingml/2006/main" xmlns:r="http://schemas.openxmlformats.org/officeDocument/2006/relationships" xmlns:p="http://schemas.openxmlformats.org/presentationml/2006/main">
+<p:sld xmlns:a="http://schemas.openxmlformats.org/drawingml/2006/main" xmlns:p="http://schemas.openxmlformats.org/presentationml/2006/main" xmlns:r="http://schemas.openxmlformats.org/officeDocument/2006/relationships">
   <p:cSld>
     <p:bg>
       <p:bgPr>
@@ -3094,14 +3099,7 @@
         <p:cNvGrpSpPr/>
         <p:nvPr/>
       </p:nvGrpSpPr>
-      <p:grpSpPr>
-        <a:xfrm>
-          <a:off x="0" y="0"/>
-          <a:ext cx="0" cy="0"/>
-          <a:chOff x="0" y="0"/>
-          <a:chExt cx="0" cy="0"/>
-        </a:xfrm>
-      </p:grpSpPr>
+      <p:grpSpPr/>
       <p:sp>
         <p:nvSpPr>
           <p:cNvPr id="2" name="Rectangle 1"/>
@@ -3142,7 +3140,6 @@
           <a:lstStyle/>
           <a:p>
             <a:pPr algn="ctr"/>
-            <a:endParaRPr/>
           </a:p>
         </p:txBody>
       </p:sp>
@@ -3186,7 +3183,6 @@
           <a:lstStyle/>
           <a:p>
             <a:pPr algn="ctr"/>
-            <a:endParaRPr/>
           </a:p>
         </p:txBody>
       </p:sp>
@@ -3230,7 +3226,6 @@
           <a:lstStyle/>
           <a:p>
             <a:pPr algn="ctr"/>
-            <a:endParaRPr/>
           </a:p>
         </p:txBody>
       </p:sp>
@@ -3274,7 +3269,6 @@
           <a:lstStyle/>
           <a:p>
             <a:pPr algn="ctr"/>
-            <a:endParaRPr/>
           </a:p>
         </p:txBody>
       </p:sp>
@@ -3386,7 +3380,6 @@
           <a:lstStyle/>
           <a:p>
             <a:pPr algn="ctr"/>
-            <a:endParaRPr/>
           </a:p>
         </p:txBody>
       </p:sp>
@@ -3534,7 +3527,6 @@
           <a:lstStyle/>
           <a:p>
             <a:pPr algn="ctr"/>
-            <a:endParaRPr/>
           </a:p>
         </p:txBody>
       </p:sp>
@@ -3578,7 +3570,6 @@
           <a:lstStyle/>
           <a:p>
             <a:pPr algn="ctr"/>
-            <a:endParaRPr/>
           </a:p>
         </p:txBody>
       </p:sp>
@@ -3726,7 +3717,6 @@
           <a:lstStyle/>
           <a:p>
             <a:pPr algn="ctr"/>
-            <a:endParaRPr/>
           </a:p>
         </p:txBody>
       </p:sp>
@@ -3770,7 +3760,6 @@
           <a:lstStyle/>
           <a:p>
             <a:pPr algn="ctr"/>
-            <a:endParaRPr/>
           </a:p>
         </p:txBody>
       </p:sp>
@@ -3918,7 +3907,6 @@
           <a:lstStyle/>
           <a:p>
             <a:pPr algn="ctr"/>
-            <a:endParaRPr/>
           </a:p>
         </p:txBody>
       </p:sp>
@@ -3962,7 +3950,6 @@
           <a:lstStyle/>
           <a:p>
             <a:pPr algn="ctr"/>
-            <a:endParaRPr/>
           </a:p>
         </p:txBody>
       </p:sp>
@@ -4110,7 +4097,6 @@
           <a:lstStyle/>
           <a:p>
             <a:pPr algn="ctr"/>
-            <a:endParaRPr/>
           </a:p>
         </p:txBody>
       </p:sp>
@@ -4154,7 +4140,6 @@
           <a:lstStyle/>
           <a:p>
             <a:pPr algn="ctr"/>
-            <a:endParaRPr/>
           </a:p>
         </p:txBody>
       </p:sp>
@@ -4302,7 +4287,6 @@
           <a:lstStyle/>
           <a:p>
             <a:pPr algn="ctr"/>
-            <a:endParaRPr/>
           </a:p>
         </p:txBody>
       </p:sp>
@@ -4346,7 +4330,6 @@
           <a:lstStyle/>
           <a:p>
             <a:pPr algn="ctr"/>
-            <a:endParaRPr/>
           </a:p>
         </p:txBody>
       </p:sp>
@@ -4494,7 +4477,6 @@
           <a:lstStyle/>
           <a:p>
             <a:pPr algn="ctr"/>
-            <a:endParaRPr/>
           </a:p>
         </p:txBody>
       </p:sp>
@@ -4538,7 +4520,6 @@
           <a:lstStyle/>
           <a:p>
             <a:pPr algn="ctr"/>
-            <a:endParaRPr/>
           </a:p>
         </p:txBody>
       </p:sp>
@@ -4673,7 +4654,7 @@
                   <a:srgbClr val="F59E0B"/>
                 </a:solidFill>
               </a:rPr>
-              <a:t>11</a:t>
+              <a:t>3</a:t>
             </a:r>
           </a:p>
         </p:txBody>
@@ -4707,7 +4688,7 @@
                   <a:srgbClr val="64748B"/>
                 </a:solidFill>
               </a:rPr>
-              <a:t>Nodes</a:t>
+              <a:t>Agents</a:t>
             </a:r>
           </a:p>
         </p:txBody>
@@ -4741,7 +4722,7 @@
                   <a:srgbClr val="F59E0B"/>
                 </a:solidFill>
               </a:rPr>
-              <a:t>7</a:t>
+              <a:t>8</a:t>
             </a:r>
           </a:p>
         </p:txBody>
@@ -4775,7 +4756,7 @@
                   <a:srgbClr val="64748B"/>
                 </a:solidFill>
               </a:rPr>
-              <a:t>AI Agents</a:t>
+              <a:t>Pipeline Steps</a:t>
             </a:r>
           </a:p>
         </p:txBody>
@@ -4925,7 +4906,7 @@
 </file>
 
 <file path=ppt/slides/slide2.xml><?xml version="1.0" encoding="utf-8"?>
-<p:sld xmlns:a="http://schemas.openxmlformats.org/drawingml/2006/main" xmlns:r="http://schemas.openxmlformats.org/officeDocument/2006/relationships" xmlns:p="http://schemas.openxmlformats.org/presentationml/2006/main">
+<p:sld xmlns:a="http://schemas.openxmlformats.org/drawingml/2006/main" xmlns:p="http://schemas.openxmlformats.org/presentationml/2006/main" xmlns:r="http://schemas.openxmlformats.org/officeDocument/2006/relationships">
   <p:cSld>
     <p:bg>
       <p:bgPr>
@@ -4941,14 +4922,7 @@
         <p:cNvGrpSpPr/>
         <p:nvPr/>
       </p:nvGrpSpPr>
-      <p:grpSpPr>
-        <a:xfrm>
-          <a:off x="0" y="0"/>
-          <a:ext cx="0" cy="0"/>
-          <a:chOff x="0" y="0"/>
-          <a:chExt cx="0" cy="0"/>
-        </a:xfrm>
-      </p:grpSpPr>
+      <p:grpSpPr/>
       <p:sp>
         <p:nvSpPr>
           <p:cNvPr id="2" name="Rectangle 1"/>
@@ -4989,7 +4963,6 @@
           <a:lstStyle/>
           <a:p>
             <a:pPr algn="ctr"/>
-            <a:endParaRPr/>
           </a:p>
         </p:txBody>
       </p:sp>
@@ -5103,7 +5076,6 @@
           <a:lstStyle/>
           <a:p>
             <a:pPr algn="ctr"/>
-            <a:endParaRPr/>
           </a:p>
         </p:txBody>
       </p:sp>
@@ -5147,7 +5119,6 @@
           <a:lstStyle/>
           <a:p>
             <a:pPr algn="ctr"/>
-            <a:endParaRPr/>
           </a:p>
         </p:txBody>
       </p:sp>
@@ -5297,7 +5268,6 @@
           <a:lstStyle/>
           <a:p>
             <a:pPr algn="ctr"/>
-            <a:endParaRPr/>
           </a:p>
         </p:txBody>
       </p:sp>
@@ -5341,7 +5311,6 @@
           <a:lstStyle/>
           <a:p>
             <a:pPr algn="ctr"/>
-            <a:endParaRPr/>
           </a:p>
         </p:txBody>
       </p:sp>
@@ -5491,7 +5460,6 @@
           <a:lstStyle/>
           <a:p>
             <a:pPr algn="ctr"/>
-            <a:endParaRPr/>
           </a:p>
         </p:txBody>
       </p:sp>
@@ -5535,7 +5503,6 @@
           <a:lstStyle/>
           <a:p>
             <a:pPr algn="ctr"/>
-            <a:endParaRPr/>
           </a:p>
         </p:txBody>
       </p:sp>
@@ -5719,7 +5686,6 @@
           <a:lstStyle/>
           <a:p>
             <a:pPr algn="ctr"/>
-            <a:endParaRPr/>
           </a:p>
         </p:txBody>
       </p:sp>
@@ -5763,7 +5729,6 @@
           <a:lstStyle/>
           <a:p>
             <a:pPr algn="ctr"/>
-            <a:endParaRPr/>
           </a:p>
         </p:txBody>
       </p:sp>
@@ -5911,7 +5876,6 @@
           <a:lstStyle/>
           <a:p>
             <a:pPr algn="ctr"/>
-            <a:endParaRPr/>
           </a:p>
         </p:txBody>
       </p:sp>
@@ -5955,7 +5919,6 @@
           <a:lstStyle/>
           <a:p>
             <a:pPr algn="ctr"/>
-            <a:endParaRPr/>
           </a:p>
         </p:txBody>
       </p:sp>
@@ -6103,7 +6066,6 @@
           <a:lstStyle/>
           <a:p>
             <a:pPr algn="ctr"/>
-            <a:endParaRPr/>
           </a:p>
         </p:txBody>
       </p:sp>
@@ -6147,7 +6109,6 @@
           <a:lstStyle/>
           <a:p>
             <a:pPr algn="ctr"/>
-            <a:endParaRPr/>
           </a:p>
         </p:txBody>
       </p:sp>
@@ -6180,7 +6141,7 @@
                   <a:srgbClr val="10B981"/>
                 </a:solidFill>
               </a:rPr>
-              <a:t>🤖  My AI assistant (1 query)</a:t>
+              <a:t>🤖  Our AI (1 query)</a:t>
             </a:r>
           </a:p>
         </p:txBody>
@@ -6248,7 +6209,7 @@
                   <a:srgbClr val="64748B"/>
                 </a:solidFill>
               </a:rPr>
-              <a:t>1,000 queries ≈ $8</a:t>
+              <a:t>incl. RAGAS eval  •  1,000 queries ≈ $8</a:t>
             </a:r>
           </a:p>
         </p:txBody>
@@ -6295,7 +6256,6 @@
           <a:lstStyle/>
           <a:p>
             <a:pPr algn="ctr"/>
-            <a:endParaRPr/>
           </a:p>
         </p:txBody>
       </p:sp>
@@ -6342,7 +6302,7 @@
 </file>
 
 <file path=ppt/slides/slide3.xml><?xml version="1.0" encoding="utf-8"?>
-<p:sld xmlns:a="http://schemas.openxmlformats.org/drawingml/2006/main" xmlns:r="http://schemas.openxmlformats.org/officeDocument/2006/relationships" xmlns:p="http://schemas.openxmlformats.org/presentationml/2006/main">
+<p:sld xmlns:a="http://schemas.openxmlformats.org/drawingml/2006/main" xmlns:p="http://schemas.openxmlformats.org/presentationml/2006/main" xmlns:r="http://schemas.openxmlformats.org/officeDocument/2006/relationships">
   <p:cSld>
     <p:bg>
       <p:bgPr>
@@ -6358,14 +6318,7 @@
         <p:cNvGrpSpPr/>
         <p:nvPr/>
       </p:nvGrpSpPr>
-      <p:grpSpPr>
-        <a:xfrm>
-          <a:off x="0" y="0"/>
-          <a:ext cx="0" cy="0"/>
-          <a:chOff x="0" y="0"/>
-          <a:chExt cx="0" cy="0"/>
-        </a:xfrm>
-      </p:grpSpPr>
+      <p:grpSpPr/>
       <p:sp>
         <p:nvSpPr>
           <p:cNvPr id="2" name="Rectangle 1"/>
@@ -6406,7 +6359,6 @@
           <a:lstStyle/>
           <a:p>
             <a:pPr algn="ctr"/>
-            <a:endParaRPr/>
           </a:p>
         </p:txBody>
       </p:sp>
@@ -6520,7 +6472,6 @@
           <a:lstStyle/>
           <a:p>
             <a:pPr algn="ctr"/>
-            <a:endParaRPr/>
           </a:p>
         </p:txBody>
       </p:sp>
@@ -6564,7 +6515,6 @@
           <a:lstStyle/>
           <a:p>
             <a:pPr algn="ctr"/>
-            <a:endParaRPr/>
           </a:p>
         </p:txBody>
       </p:sp>
@@ -6666,7 +6616,8 @@
                 </a:solidFill>
               </a:rPr>
               <a:t>Agentic orchestration
-11 nodes, conditional routing</a:t>
+3 agents, 8 pipeline steps
+TypedDict state management</a:t>
             </a:r>
           </a:p>
         </p:txBody>
@@ -6713,7 +6664,6 @@
           <a:lstStyle/>
           <a:p>
             <a:pPr algn="ctr"/>
-            <a:endParaRPr/>
           </a:p>
         </p:txBody>
       </p:sp>
@@ -6757,7 +6707,6 @@
           <a:lstStyle/>
           <a:p>
             <a:pPr algn="ctr"/>
-            <a:endParaRPr/>
           </a:p>
         </p:txBody>
       </p:sp>
@@ -6860,7 +6809,7 @@
               </a:rPr>
               <a:t>LLM for all agents
 Generation, grading
-&amp; re-ranking</a:t>
+&amp; reasoning</a:t>
             </a:r>
           </a:p>
         </p:txBody>
@@ -6907,7 +6856,6 @@
           <a:lstStyle/>
           <a:p>
             <a:pPr algn="ctr"/>
-            <a:endParaRPr/>
           </a:p>
         </p:txBody>
       </p:sp>
@@ -6951,7 +6899,6 @@
           <a:lstStyle/>
           <a:p>
             <a:pPr algn="ctr"/>
-            <a:endParaRPr/>
           </a:p>
         </p:txBody>
       </p:sp>
@@ -7101,7 +7048,6 @@
           <a:lstStyle/>
           <a:p>
             <a:pPr algn="ctr"/>
-            <a:endParaRPr/>
           </a:p>
         </p:txBody>
       </p:sp>
@@ -7145,7 +7091,6 @@
           <a:lstStyle/>
           <a:p>
             <a:pPr algn="ctr"/>
-            <a:endParaRPr/>
           </a:p>
         </p:txBody>
       </p:sp>
@@ -7295,7 +7240,6 @@
           <a:lstStyle/>
           <a:p>
             <a:pPr algn="ctr"/>
-            <a:endParaRPr/>
           </a:p>
         </p:txBody>
       </p:sp>
@@ -7339,7 +7283,6 @@
           <a:lstStyle/>
           <a:p>
             <a:pPr algn="ctr"/>
-            <a:endParaRPr/>
           </a:p>
         </p:txBody>
       </p:sp>
@@ -7420,7 +7363,7 @@
         <p:spPr>
           <a:xfrm>
             <a:off x="457200" y="4370832"/>
-            <a:ext cx="2514600" cy="646331"/>
+            <a:ext cx="2514600" cy="1554480"/>
           </a:xfrm>
           <a:prstGeom prst="rect">
             <a:avLst/>
@@ -7435,14 +7378,14 @@
           <a:p>
             <a:pPr algn="l"/>
             <a:r>
-              <a:rPr sz="1200" b="0" i="0" dirty="0">
+              <a:rPr sz="1200" b="0" i="0">
                 <a:solidFill>
                   <a:srgbClr val="64748B"/>
                 </a:solidFill>
               </a:rPr>
               <a:t>gpt-4o-mini as judge
 Faithfulness + Relevancy
-</a:t>
+~$0.001 per eval</a:t>
             </a:r>
           </a:p>
         </p:txBody>
@@ -7489,7 +7432,6 @@
           <a:lstStyle/>
           <a:p>
             <a:pPr algn="ctr"/>
-            <a:endParaRPr/>
           </a:p>
         </p:txBody>
       </p:sp>
@@ -7533,7 +7475,6 @@
           <a:lstStyle/>
           <a:p>
             <a:pPr algn="ctr"/>
-            <a:endParaRPr/>
           </a:p>
         </p:txBody>
       </p:sp>
@@ -7683,7 +7624,6 @@
           <a:lstStyle/>
           <a:p>
             <a:pPr algn="ctr"/>
-            <a:endParaRPr/>
           </a:p>
         </p:txBody>
       </p:sp>
@@ -7727,7 +7667,6 @@
           <a:lstStyle/>
           <a:p>
             <a:pPr algn="ctr"/>
-            <a:endParaRPr/>
           </a:p>
         </p:txBody>
       </p:sp>
@@ -7877,7 +7816,6 @@
           <a:lstStyle/>
           <a:p>
             <a:pPr algn="ctr"/>
-            <a:endParaRPr/>
           </a:p>
         </p:txBody>
       </p:sp>
@@ -7921,7 +7859,6 @@
           <a:lstStyle/>
           <a:p>
             <a:pPr algn="ctr"/>
-            <a:endParaRPr/>
           </a:p>
         </p:txBody>
       </p:sp>
@@ -8038,7 +7975,7 @@
 </file>
 
 <file path=ppt/slides/slide4.xml><?xml version="1.0" encoding="utf-8"?>
-<p:sld xmlns:a="http://schemas.openxmlformats.org/drawingml/2006/main" xmlns:r="http://schemas.openxmlformats.org/officeDocument/2006/relationships" xmlns:p="http://schemas.openxmlformats.org/presentationml/2006/main">
+<p:sld xmlns:a="http://schemas.openxmlformats.org/drawingml/2006/main" xmlns:p="http://schemas.openxmlformats.org/presentationml/2006/main" xmlns:r="http://schemas.openxmlformats.org/officeDocument/2006/relationships">
   <p:cSld>
     <p:bg>
       <p:bgPr>
@@ -8054,14 +7991,7 @@
         <p:cNvGrpSpPr/>
         <p:nvPr/>
       </p:nvGrpSpPr>
-      <p:grpSpPr>
-        <a:xfrm>
-          <a:off x="0" y="0"/>
-          <a:ext cx="0" cy="0"/>
-          <a:chOff x="0" y="0"/>
-          <a:chExt cx="0" cy="0"/>
-        </a:xfrm>
-      </p:grpSpPr>
+      <p:grpSpPr/>
       <p:sp>
         <p:nvSpPr>
           <p:cNvPr id="2" name="Rectangle 1"/>
@@ -8102,7 +8032,6 @@
           <a:lstStyle/>
           <a:p>
             <a:pPr algn="ctr"/>
-            <a:endParaRPr/>
           </a:p>
         </p:txBody>
       </p:sp>
@@ -8169,20 +8098,14 @@
                   <a:srgbClr val="BFDBF7"/>
                 </a:solidFill>
               </a:rPr>
-              <a:t>Agentic RAG with retry loop — 11 nodes, 7 agents</a:t>
+              <a:t>Agentic RAG with retry loop — 3 specialized agents, 8 pipeline steps</a:t>
             </a:r>
           </a:p>
         </p:txBody>
       </p:sp>
       <p:pic>
         <p:nvPicPr>
-          <p:cNvPr id="7" name="Рисунок 6">
-            <a:extLst>
-              <a:ext uri="{FF2B5EF4-FFF2-40B4-BE49-F238E27FC236}">
-                <a16:creationId xmlns:a16="http://schemas.microsoft.com/office/drawing/2014/main" id="{FAF77E82-4F10-F16A-B1F4-6AF6252873A8}"/>
-              </a:ext>
-            </a:extLst>
-          </p:cNvPr>
+          <p:cNvPr id="5" name="Picture 4" descr="architecture_diagram_v4.png"/>
           <p:cNvPicPr>
             <a:picLocks noChangeAspect="1"/>
           </p:cNvPicPr>
@@ -8196,8 +8119,8 @@
         </p:blipFill>
         <p:spPr>
           <a:xfrm>
-            <a:off x="642968" y="1188720"/>
-            <a:ext cx="10902889" cy="5623560"/>
+            <a:off x="182880" y="1207008"/>
+            <a:ext cx="11823192" cy="5468112"/>
           </a:xfrm>
           <a:prstGeom prst="rect">
             <a:avLst/>
@@ -8213,7 +8136,7 @@
 </file>
 
 <file path=ppt/slides/slide5.xml><?xml version="1.0" encoding="utf-8"?>
-<p:sld xmlns:a="http://schemas.openxmlformats.org/drawingml/2006/main" xmlns:r="http://schemas.openxmlformats.org/officeDocument/2006/relationships" xmlns:p="http://schemas.openxmlformats.org/presentationml/2006/main">
+<p:sld xmlns:a="http://schemas.openxmlformats.org/drawingml/2006/main" xmlns:p="http://schemas.openxmlformats.org/presentationml/2006/main" xmlns:r="http://schemas.openxmlformats.org/officeDocument/2006/relationships">
   <p:cSld>
     <p:bg>
       <p:bgPr>
@@ -8229,14 +8152,7 @@
         <p:cNvGrpSpPr/>
         <p:nvPr/>
       </p:nvGrpSpPr>
-      <p:grpSpPr>
-        <a:xfrm>
-          <a:off x="0" y="0"/>
-          <a:ext cx="0" cy="0"/>
-          <a:chOff x="0" y="0"/>
-          <a:chExt cx="0" cy="0"/>
-        </a:xfrm>
-      </p:grpSpPr>
+      <p:grpSpPr/>
       <p:sp>
         <p:nvSpPr>
           <p:cNvPr id="2" name="Rectangle 1"/>
@@ -8277,7 +8193,6 @@
           <a:lstStyle/>
           <a:p>
             <a:pPr algn="ctr"/>
-            <a:endParaRPr/>
           </a:p>
         </p:txBody>
       </p:sp>

</xml_diff>